<commit_message>
Updated slides with other projects chapter
</commit_message>
<xml_diff>
--- a/resources/presentation/temp.pptx
+++ b/resources/presentation/temp.pptx
@@ -7,6 +7,7 @@
   <p:sldIdLst>
     <p:sldId id="256" r:id="rId2"/>
     <p:sldId id="257" r:id="rId3"/>
+    <p:sldId id="275" r:id="rId4"/>
   </p:sldIdLst>
   <p:sldSz cx="12192000" cy="6858000"/>
   <p:notesSz cx="6858000" cy="9144000"/>
@@ -105,6 +106,11 @@
       </a:defRPr>
     </a:lvl9pPr>
   </p:defaultTextStyle>
+  <p:extLst>
+    <p:ext uri="{EFAFB233-063F-42B5-8137-9DF3F51BA10A}">
+      <p15:sldGuideLst xmlns:p15="http://schemas.microsoft.com/office/powerpoint/2012/main"/>
+    </p:ext>
+  </p:extLst>
 </p:presentation>
 </file>
 
@@ -255,7 +261,7 @@
           <a:p>
             <a:fld id="{0D586318-8C7C-4325-8CF8-A34554021360}" type="datetimeFigureOut">
               <a:rPr lang="en-US" smtClean="0"/>
-              <a:t>9/14/2026</a:t>
+              <a:t>9/22/2026</a:t>
             </a:fld>
             <a:endParaRPr lang="en-US"/>
           </a:p>
@@ -453,7 +459,7 @@
           <a:p>
             <a:fld id="{0D586318-8C7C-4325-8CF8-A34554021360}" type="datetimeFigureOut">
               <a:rPr lang="en-US" smtClean="0"/>
-              <a:t>9/14/2026</a:t>
+              <a:t>9/22/2026</a:t>
             </a:fld>
             <a:endParaRPr lang="en-US"/>
           </a:p>
@@ -661,7 +667,7 @@
           <a:p>
             <a:fld id="{0D586318-8C7C-4325-8CF8-A34554021360}" type="datetimeFigureOut">
               <a:rPr lang="en-US" smtClean="0"/>
-              <a:t>9/14/2026</a:t>
+              <a:t>9/22/2026</a:t>
             </a:fld>
             <a:endParaRPr lang="en-US"/>
           </a:p>
@@ -859,7 +865,7 @@
           <a:p>
             <a:fld id="{0D586318-8C7C-4325-8CF8-A34554021360}" type="datetimeFigureOut">
               <a:rPr lang="en-US" smtClean="0"/>
-              <a:t>9/14/2026</a:t>
+              <a:t>9/22/2026</a:t>
             </a:fld>
             <a:endParaRPr lang="en-US"/>
           </a:p>
@@ -1134,7 +1140,7 @@
           <a:p>
             <a:fld id="{0D586318-8C7C-4325-8CF8-A34554021360}" type="datetimeFigureOut">
               <a:rPr lang="en-US" smtClean="0"/>
-              <a:t>9/14/2026</a:t>
+              <a:t>9/22/2026</a:t>
             </a:fld>
             <a:endParaRPr lang="en-US"/>
           </a:p>
@@ -1399,7 +1405,7 @@
           <a:p>
             <a:fld id="{0D586318-8C7C-4325-8CF8-A34554021360}" type="datetimeFigureOut">
               <a:rPr lang="en-US" smtClean="0"/>
-              <a:t>9/14/2026</a:t>
+              <a:t>9/22/2026</a:t>
             </a:fld>
             <a:endParaRPr lang="en-US"/>
           </a:p>
@@ -1811,7 +1817,7 @@
           <a:p>
             <a:fld id="{0D586318-8C7C-4325-8CF8-A34554021360}" type="datetimeFigureOut">
               <a:rPr lang="en-US" smtClean="0"/>
-              <a:t>9/14/2026</a:t>
+              <a:t>9/22/2026</a:t>
             </a:fld>
             <a:endParaRPr lang="en-US"/>
           </a:p>
@@ -1952,7 +1958,7 @@
           <a:p>
             <a:fld id="{0D586318-8C7C-4325-8CF8-A34554021360}" type="datetimeFigureOut">
               <a:rPr lang="en-US" smtClean="0"/>
-              <a:t>9/14/2026</a:t>
+              <a:t>9/22/2026</a:t>
             </a:fld>
             <a:endParaRPr lang="en-US"/>
           </a:p>
@@ -2065,7 +2071,7 @@
           <a:p>
             <a:fld id="{0D586318-8C7C-4325-8CF8-A34554021360}" type="datetimeFigureOut">
               <a:rPr lang="en-US" smtClean="0"/>
-              <a:t>9/14/2026</a:t>
+              <a:t>9/22/2026</a:t>
             </a:fld>
             <a:endParaRPr lang="en-US"/>
           </a:p>
@@ -2376,7 +2382,7 @@
           <a:p>
             <a:fld id="{0D586318-8C7C-4325-8CF8-A34554021360}" type="datetimeFigureOut">
               <a:rPr lang="en-US" smtClean="0"/>
-              <a:t>9/14/2026</a:t>
+              <a:t>9/22/2026</a:t>
             </a:fld>
             <a:endParaRPr lang="en-US"/>
           </a:p>
@@ -2664,7 +2670,7 @@
           <a:p>
             <a:fld id="{0D586318-8C7C-4325-8CF8-A34554021360}" type="datetimeFigureOut">
               <a:rPr lang="en-US" smtClean="0"/>
-              <a:t>9/14/2026</a:t>
+              <a:t>9/22/2026</a:t>
             </a:fld>
             <a:endParaRPr lang="en-US"/>
           </a:p>
@@ -2905,7 +2911,7 @@
           <a:p>
             <a:fld id="{0D586318-8C7C-4325-8CF8-A34554021360}" type="datetimeFigureOut">
               <a:rPr lang="en-US" smtClean="0"/>
-              <a:t>9/14/2026</a:t>
+              <a:t>9/22/2026</a:t>
             </a:fld>
             <a:endParaRPr lang="en-US"/>
           </a:p>
@@ -3869,6 +3875,900 @@
 </p:sld>
 </file>
 
+<file path=ppt/slides/slide3.xml><?xml version="1.0" encoding="utf-8"?>
+<p:sld xmlns:a="http://schemas.openxmlformats.org/drawingml/2006/main" xmlns:r="http://schemas.openxmlformats.org/officeDocument/2006/relationships" xmlns:p="http://schemas.openxmlformats.org/presentationml/2006/main">
+  <p:cSld>
+    <p:spTree>
+      <p:nvGrpSpPr>
+        <p:cNvPr id="1" name=""/>
+        <p:cNvGrpSpPr/>
+        <p:nvPr/>
+      </p:nvGrpSpPr>
+      <p:grpSpPr>
+        <a:xfrm>
+          <a:off x="0" y="0"/>
+          <a:ext cx="0" cy="0"/>
+          <a:chOff x="0" y="0"/>
+          <a:chExt cx="0" cy="0"/>
+        </a:xfrm>
+      </p:grpSpPr>
+      <p:sp>
+        <p:nvSpPr>
+          <p:cNvPr id="2" name="Title 1">
+            <a:extLst>
+              <a:ext uri="{FF2B5EF4-FFF2-40B4-BE49-F238E27FC236}">
+                <a16:creationId xmlns:a16="http://schemas.microsoft.com/office/drawing/2014/main" id="{187A26E2-F5FF-2BBD-C79F-9C1306247CAC}"/>
+              </a:ext>
+            </a:extLst>
+          </p:cNvPr>
+          <p:cNvSpPr>
+            <a:spLocks noGrp="1"/>
+          </p:cNvSpPr>
+          <p:nvPr>
+            <p:ph type="title"/>
+          </p:nvPr>
+        </p:nvSpPr>
+        <p:spPr/>
+        <p:txBody>
+          <a:bodyPr/>
+          <a:lstStyle/>
+          <a:p>
+            <a:r>
+              <a:rPr lang="en-US" dirty="0"/>
+              <a:t>4 Other Projects</a:t>
+            </a:r>
+            <a:br>
+              <a:rPr lang="en-US" dirty="0"/>
+            </a:br>
+            <a:endParaRPr lang="en-US" dirty="0"/>
+          </a:p>
+        </p:txBody>
+      </p:sp>
+      <p:sp>
+        <p:nvSpPr>
+          <p:cNvPr id="3" name="TextBox 2">
+            <a:extLst>
+              <a:ext uri="{FF2B5EF4-FFF2-40B4-BE49-F238E27FC236}">
+                <a16:creationId xmlns:a16="http://schemas.microsoft.com/office/drawing/2014/main" id="{A1E2E5AD-1377-FB88-B823-076968E13A42}"/>
+              </a:ext>
+            </a:extLst>
+          </p:cNvPr>
+          <p:cNvSpPr txBox="1"/>
+          <p:nvPr/>
+        </p:nvSpPr>
+        <p:spPr>
+          <a:xfrm>
+            <a:off x="1486895" y="1280160"/>
+            <a:ext cx="7132319" cy="4874150"/>
+          </a:xfrm>
+          <a:prstGeom prst="rect">
+            <a:avLst/>
+          </a:prstGeom>
+          <a:noFill/>
+        </p:spPr>
+        <p:txBody>
+          <a:bodyPr wrap="square" lIns="0" tIns="0" rIns="0" bIns="0" rtlCol="0">
+            <a:noAutofit/>
+          </a:bodyPr>
+          <a:lstStyle/>
+          <a:p>
+            <a:pPr algn="l"/>
+            <a:r>
+              <a:rPr lang="en-US" dirty="0"/>
+              <a:t>Target: Automated inspection of Gas Insulated Switchgear</a:t>
+            </a:r>
+          </a:p>
+          <a:p>
+            <a:pPr algn="l"/>
+            <a:endParaRPr lang="en-US" dirty="0"/>
+          </a:p>
+          <a:p>
+            <a:pPr algn="l"/>
+            <a:r>
+              <a:rPr lang="en-US" dirty="0"/>
+              <a:t>Objective: Appearance features of a Gas Insulated Switchgear (GIS)</a:t>
+            </a:r>
+          </a:p>
+          <a:p>
+            <a:pPr algn="l"/>
+            <a:endParaRPr lang="en-US" dirty="0"/>
+          </a:p>
+          <a:p>
+            <a:pPr algn="l"/>
+            <a:endParaRPr lang="en-US" dirty="0"/>
+          </a:p>
+          <a:p>
+            <a:pPr algn="l"/>
+            <a:endParaRPr lang="en-US" dirty="0"/>
+          </a:p>
+          <a:p>
+            <a:pPr algn="l"/>
+            <a:endParaRPr lang="en-US" dirty="0"/>
+          </a:p>
+          <a:p>
+            <a:pPr algn="l"/>
+            <a:endParaRPr lang="en-US" dirty="0"/>
+          </a:p>
+          <a:p>
+            <a:pPr algn="l"/>
+            <a:endParaRPr lang="en-US" dirty="0"/>
+          </a:p>
+          <a:p>
+            <a:pPr algn="l"/>
+            <a:r>
+              <a:rPr lang="en-US" dirty="0"/>
+              <a:t>Conception:</a:t>
+            </a:r>
+          </a:p>
+          <a:p>
+            <a:pPr marL="285750" indent="-285750" algn="l">
+              <a:buFontTx/>
+              <a:buChar char="-"/>
+            </a:pPr>
+            <a:r>
+              <a:rPr lang="en-US" dirty="0"/>
+              <a:t>Several robot arms equipped with high-resolution cameras </a:t>
+            </a:r>
+          </a:p>
+          <a:p>
+            <a:pPr marL="285750" indent="-285750" algn="l">
+              <a:buFontTx/>
+              <a:buChar char="-"/>
+            </a:pPr>
+            <a:r>
+              <a:rPr lang="en-US" dirty="0"/>
+              <a:t>AI trained models with high accuracy at inspection</a:t>
+            </a:r>
+          </a:p>
+          <a:p>
+            <a:pPr marL="285750" indent="-285750" algn="l">
+              <a:buFontTx/>
+              <a:buChar char="-"/>
+            </a:pPr>
+            <a:r>
+              <a:rPr lang="en-US" dirty="0"/>
+              <a:t>Three level of defects detection</a:t>
+            </a:r>
+          </a:p>
+          <a:p>
+            <a:pPr marL="742950" lvl="1" indent="-285750">
+              <a:buFontTx/>
+              <a:buChar char="-"/>
+            </a:pPr>
+            <a:r>
+              <a:rPr lang="en-US" dirty="0"/>
+              <a:t>First level: surface finish</a:t>
+            </a:r>
+          </a:p>
+          <a:p>
+            <a:pPr marL="742950" lvl="1" indent="-285750">
+              <a:buFontTx/>
+              <a:buChar char="-"/>
+            </a:pPr>
+            <a:r>
+              <a:rPr lang="en-US" dirty="0"/>
+              <a:t>Second level: labels and painting color</a:t>
+            </a:r>
+          </a:p>
+          <a:p>
+            <a:pPr marL="742950" lvl="1" indent="-285750">
+              <a:buFontTx/>
+              <a:buChar char="-"/>
+            </a:pPr>
+            <a:r>
+              <a:rPr lang="en-US" dirty="0"/>
+              <a:t>Third level: structural conformance to the drawing</a:t>
+            </a:r>
+          </a:p>
+          <a:p>
+            <a:pPr marL="285750" indent="-285750" algn="l">
+              <a:buFontTx/>
+              <a:buChar char="-"/>
+            </a:pPr>
+            <a:endParaRPr lang="en-US" dirty="0"/>
+          </a:p>
+          <a:p>
+            <a:pPr algn="l"/>
+            <a:endParaRPr lang="en-US" dirty="0"/>
+          </a:p>
+          <a:p>
+            <a:pPr algn="l"/>
+            <a:endParaRPr lang="en-US" dirty="0"/>
+          </a:p>
+        </p:txBody>
+      </p:sp>
+      <p:graphicFrame>
+        <p:nvGraphicFramePr>
+          <p:cNvPr id="5" name="Table 4">
+            <a:extLst>
+              <a:ext uri="{FF2B5EF4-FFF2-40B4-BE49-F238E27FC236}">
+                <a16:creationId xmlns:a16="http://schemas.microsoft.com/office/drawing/2014/main" id="{7ADF219F-EF2E-BD46-5F6D-D55931F25E5F}"/>
+              </a:ext>
+            </a:extLst>
+          </p:cNvPr>
+          <p:cNvGraphicFramePr>
+            <a:graphicFrameLocks noGrp="1"/>
+          </p:cNvGraphicFramePr>
+          <p:nvPr/>
+        </p:nvGraphicFramePr>
+        <p:xfrm>
+          <a:off x="1486895" y="2241735"/>
+          <a:ext cx="6718823" cy="1112520"/>
+        </p:xfrm>
+        <a:graphic>
+          <a:graphicData uri="http://schemas.openxmlformats.org/drawingml/2006/table">
+            <a:tbl>
+              <a:tblPr firstRow="1" bandRow="1">
+                <a:tableStyleId>{2D5ABB26-0587-4C30-8999-92F81FD0307C}</a:tableStyleId>
+              </a:tblPr>
+              <a:tblGrid>
+                <a:gridCol w="1398090">
+                  <a:extLst>
+                    <a:ext uri="{9D8B030D-6E8A-4147-A177-3AD203B41FA5}">
+                      <a16:colId xmlns:a16="http://schemas.microsoft.com/office/drawing/2014/main" val="3696000342"/>
+                    </a:ext>
+                  </a:extLst>
+                </a:gridCol>
+                <a:gridCol w="2066470">
+                  <a:extLst>
+                    <a:ext uri="{9D8B030D-6E8A-4147-A177-3AD203B41FA5}">
+                      <a16:colId xmlns:a16="http://schemas.microsoft.com/office/drawing/2014/main" val="3095061570"/>
+                    </a:ext>
+                  </a:extLst>
+                </a:gridCol>
+                <a:gridCol w="1567180">
+                  <a:extLst>
+                    <a:ext uri="{9D8B030D-6E8A-4147-A177-3AD203B41FA5}">
+                      <a16:colId xmlns:a16="http://schemas.microsoft.com/office/drawing/2014/main" val="100395554"/>
+                    </a:ext>
+                  </a:extLst>
+                </a:gridCol>
+                <a:gridCol w="1687083">
+                  <a:extLst>
+                    <a:ext uri="{9D8B030D-6E8A-4147-A177-3AD203B41FA5}">
+                      <a16:colId xmlns:a16="http://schemas.microsoft.com/office/drawing/2014/main" val="462344950"/>
+                    </a:ext>
+                  </a:extLst>
+                </a:gridCol>
+              </a:tblGrid>
+              <a:tr h="370840">
+                <a:tc>
+                  <a:txBody>
+                    <a:bodyPr/>
+                    <a:lstStyle/>
+                    <a:p>
+                      <a:r>
+                        <a:rPr lang="en-US" dirty="0"/>
+                        <a:t>Nameplate</a:t>
+                      </a:r>
+                    </a:p>
+                  </a:txBody>
+                  <a:tcPr>
+                    <a:lnL w="12700" cap="flat" cmpd="sng" algn="ctr">
+                      <a:solidFill>
+                        <a:schemeClr val="tx1"/>
+                      </a:solidFill>
+                      <a:prstDash val="solid"/>
+                      <a:round/>
+                      <a:headEnd type="none" w="med" len="med"/>
+                      <a:tailEnd type="none" w="med" len="med"/>
+                    </a:lnL>
+                    <a:lnR w="12700" cap="flat" cmpd="sng" algn="ctr">
+                      <a:solidFill>
+                        <a:schemeClr val="tx1"/>
+                      </a:solidFill>
+                      <a:prstDash val="solid"/>
+                      <a:round/>
+                      <a:headEnd type="none" w="med" len="med"/>
+                      <a:tailEnd type="none" w="med" len="med"/>
+                    </a:lnR>
+                    <a:lnT w="12700" cap="flat" cmpd="sng" algn="ctr">
+                      <a:solidFill>
+                        <a:schemeClr val="tx1"/>
+                      </a:solidFill>
+                      <a:prstDash val="solid"/>
+                      <a:round/>
+                      <a:headEnd type="none" w="med" len="med"/>
+                      <a:tailEnd type="none" w="med" len="med"/>
+                    </a:lnT>
+                    <a:lnB w="12700" cap="flat" cmpd="sng" algn="ctr">
+                      <a:solidFill>
+                        <a:schemeClr val="tx1"/>
+                      </a:solidFill>
+                      <a:prstDash val="solid"/>
+                      <a:round/>
+                      <a:headEnd type="none" w="med" len="med"/>
+                      <a:tailEnd type="none" w="med" len="med"/>
+                    </a:lnB>
+                  </a:tcPr>
+                </a:tc>
+                <a:tc>
+                  <a:txBody>
+                    <a:bodyPr/>
+                    <a:lstStyle/>
+                    <a:p>
+                      <a:r>
+                        <a:rPr lang="en-US" dirty="0"/>
+                        <a:t>Coating</a:t>
+                      </a:r>
+                    </a:p>
+                  </a:txBody>
+                  <a:tcPr>
+                    <a:lnL w="12700" cap="flat" cmpd="sng" algn="ctr">
+                      <a:solidFill>
+                        <a:schemeClr val="tx1"/>
+                      </a:solidFill>
+                      <a:prstDash val="solid"/>
+                      <a:round/>
+                      <a:headEnd type="none" w="med" len="med"/>
+                      <a:tailEnd type="none" w="med" len="med"/>
+                    </a:lnL>
+                    <a:lnR w="12700" cap="flat" cmpd="sng" algn="ctr">
+                      <a:solidFill>
+                        <a:schemeClr val="tx1"/>
+                      </a:solidFill>
+                      <a:prstDash val="solid"/>
+                      <a:round/>
+                      <a:headEnd type="none" w="med" len="med"/>
+                      <a:tailEnd type="none" w="med" len="med"/>
+                    </a:lnR>
+                    <a:lnT w="12700" cap="flat" cmpd="sng" algn="ctr">
+                      <a:solidFill>
+                        <a:schemeClr val="tx1"/>
+                      </a:solidFill>
+                      <a:prstDash val="solid"/>
+                      <a:round/>
+                      <a:headEnd type="none" w="med" len="med"/>
+                      <a:tailEnd type="none" w="med" len="med"/>
+                    </a:lnT>
+                    <a:lnB w="12700" cap="flat" cmpd="sng" algn="ctr">
+                      <a:solidFill>
+                        <a:schemeClr val="tx1"/>
+                      </a:solidFill>
+                      <a:prstDash val="solid"/>
+                      <a:round/>
+                      <a:headEnd type="none" w="med" len="med"/>
+                      <a:tailEnd type="none" w="med" len="med"/>
+                    </a:lnB>
+                  </a:tcPr>
+                </a:tc>
+                <a:tc>
+                  <a:txBody>
+                    <a:bodyPr/>
+                    <a:lstStyle/>
+                    <a:p>
+                      <a:r>
+                        <a:rPr lang="en-US" dirty="0"/>
+                        <a:t>Painting</a:t>
+                      </a:r>
+                    </a:p>
+                  </a:txBody>
+                  <a:tcPr>
+                    <a:lnL w="12700" cap="flat" cmpd="sng" algn="ctr">
+                      <a:solidFill>
+                        <a:schemeClr val="tx1"/>
+                      </a:solidFill>
+                      <a:prstDash val="solid"/>
+                      <a:round/>
+                      <a:headEnd type="none" w="med" len="med"/>
+                      <a:tailEnd type="none" w="med" len="med"/>
+                    </a:lnL>
+                    <a:lnR w="12700" cap="flat" cmpd="sng" algn="ctr">
+                      <a:solidFill>
+                        <a:schemeClr val="tx1"/>
+                      </a:solidFill>
+                      <a:prstDash val="solid"/>
+                      <a:round/>
+                      <a:headEnd type="none" w="med" len="med"/>
+                      <a:tailEnd type="none" w="med" len="med"/>
+                    </a:lnR>
+                    <a:lnT w="12700" cap="flat" cmpd="sng" algn="ctr">
+                      <a:solidFill>
+                        <a:schemeClr val="tx1"/>
+                      </a:solidFill>
+                      <a:prstDash val="solid"/>
+                      <a:round/>
+                      <a:headEnd type="none" w="med" len="med"/>
+                      <a:tailEnd type="none" w="med" len="med"/>
+                    </a:lnT>
+                    <a:lnB w="12700" cap="flat" cmpd="sng" algn="ctr">
+                      <a:solidFill>
+                        <a:schemeClr val="tx1"/>
+                      </a:solidFill>
+                      <a:prstDash val="solid"/>
+                      <a:round/>
+                      <a:headEnd type="none" w="med" len="med"/>
+                      <a:tailEnd type="none" w="med" len="med"/>
+                    </a:lnB>
+                  </a:tcPr>
+                </a:tc>
+                <a:tc>
+                  <a:txBody>
+                    <a:bodyPr/>
+                    <a:lstStyle/>
+                    <a:p>
+                      <a:r>
+                        <a:rPr lang="en-US" dirty="0"/>
+                        <a:t>Modules</a:t>
+                      </a:r>
+                    </a:p>
+                  </a:txBody>
+                  <a:tcPr>
+                    <a:lnL w="12700" cap="flat" cmpd="sng" algn="ctr">
+                      <a:solidFill>
+                        <a:schemeClr val="tx1"/>
+                      </a:solidFill>
+                      <a:prstDash val="solid"/>
+                      <a:round/>
+                      <a:headEnd type="none" w="med" len="med"/>
+                      <a:tailEnd type="none" w="med" len="med"/>
+                    </a:lnL>
+                    <a:lnR w="12700" cap="flat" cmpd="sng" algn="ctr">
+                      <a:solidFill>
+                        <a:schemeClr val="tx1"/>
+                      </a:solidFill>
+                      <a:prstDash val="solid"/>
+                      <a:round/>
+                      <a:headEnd type="none" w="med" len="med"/>
+                      <a:tailEnd type="none" w="med" len="med"/>
+                    </a:lnR>
+                    <a:lnT w="12700" cap="flat" cmpd="sng" algn="ctr">
+                      <a:solidFill>
+                        <a:schemeClr val="tx1"/>
+                      </a:solidFill>
+                      <a:prstDash val="solid"/>
+                      <a:round/>
+                      <a:headEnd type="none" w="med" len="med"/>
+                      <a:tailEnd type="none" w="med" len="med"/>
+                    </a:lnT>
+                    <a:lnB w="12700" cap="flat" cmpd="sng" algn="ctr">
+                      <a:solidFill>
+                        <a:schemeClr val="tx1"/>
+                      </a:solidFill>
+                      <a:prstDash val="solid"/>
+                      <a:round/>
+                      <a:headEnd type="none" w="med" len="med"/>
+                      <a:tailEnd type="none" w="med" len="med"/>
+                    </a:lnB>
+                  </a:tcPr>
+                </a:tc>
+                <a:extLst>
+                  <a:ext uri="{0D108BD9-81ED-4DB2-BD59-A6C34878D82A}">
+                    <a16:rowId xmlns:a16="http://schemas.microsoft.com/office/drawing/2014/main" val="2198395257"/>
+                  </a:ext>
+                </a:extLst>
+              </a:tr>
+              <a:tr h="370840">
+                <a:tc>
+                  <a:txBody>
+                    <a:bodyPr/>
+                    <a:lstStyle/>
+                    <a:p>
+                      <a:r>
+                        <a:rPr lang="en-US" dirty="0"/>
+                        <a:t>Bushing</a:t>
+                      </a:r>
+                    </a:p>
+                  </a:txBody>
+                  <a:tcPr>
+                    <a:lnL w="12700" cap="flat" cmpd="sng" algn="ctr">
+                      <a:solidFill>
+                        <a:schemeClr val="tx1"/>
+                      </a:solidFill>
+                      <a:prstDash val="solid"/>
+                      <a:round/>
+                      <a:headEnd type="none" w="med" len="med"/>
+                      <a:tailEnd type="none" w="med" len="med"/>
+                    </a:lnL>
+                    <a:lnR w="12700" cap="flat" cmpd="sng" algn="ctr">
+                      <a:solidFill>
+                        <a:schemeClr val="tx1"/>
+                      </a:solidFill>
+                      <a:prstDash val="solid"/>
+                      <a:round/>
+                      <a:headEnd type="none" w="med" len="med"/>
+                      <a:tailEnd type="none" w="med" len="med"/>
+                    </a:lnR>
+                    <a:lnT w="12700" cap="flat" cmpd="sng" algn="ctr">
+                      <a:solidFill>
+                        <a:schemeClr val="tx1"/>
+                      </a:solidFill>
+                      <a:prstDash val="solid"/>
+                      <a:round/>
+                      <a:headEnd type="none" w="med" len="med"/>
+                      <a:tailEnd type="none" w="med" len="med"/>
+                    </a:lnT>
+                    <a:lnB w="12700" cap="flat" cmpd="sng" algn="ctr">
+                      <a:solidFill>
+                        <a:schemeClr val="tx1"/>
+                      </a:solidFill>
+                      <a:prstDash val="solid"/>
+                      <a:round/>
+                      <a:headEnd type="none" w="med" len="med"/>
+                      <a:tailEnd type="none" w="med" len="med"/>
+                    </a:lnB>
+                  </a:tcPr>
+                </a:tc>
+                <a:tc>
+                  <a:txBody>
+                    <a:bodyPr/>
+                    <a:lstStyle/>
+                    <a:p>
+                      <a:r>
+                        <a:rPr lang="en-US" dirty="0"/>
+                        <a:t>Gas Compartment</a:t>
+                      </a:r>
+                    </a:p>
+                  </a:txBody>
+                  <a:tcPr>
+                    <a:lnL w="12700" cap="flat" cmpd="sng" algn="ctr">
+                      <a:solidFill>
+                        <a:schemeClr val="tx1"/>
+                      </a:solidFill>
+                      <a:prstDash val="solid"/>
+                      <a:round/>
+                      <a:headEnd type="none" w="med" len="med"/>
+                      <a:tailEnd type="none" w="med" len="med"/>
+                    </a:lnL>
+                    <a:lnR w="12700" cap="flat" cmpd="sng" algn="ctr">
+                      <a:solidFill>
+                        <a:schemeClr val="tx1"/>
+                      </a:solidFill>
+                      <a:prstDash val="solid"/>
+                      <a:round/>
+                      <a:headEnd type="none" w="med" len="med"/>
+                      <a:tailEnd type="none" w="med" len="med"/>
+                    </a:lnR>
+                    <a:lnT w="12700" cap="flat" cmpd="sng" algn="ctr">
+                      <a:solidFill>
+                        <a:schemeClr val="tx1"/>
+                      </a:solidFill>
+                      <a:prstDash val="solid"/>
+                      <a:round/>
+                      <a:headEnd type="none" w="med" len="med"/>
+                      <a:tailEnd type="none" w="med" len="med"/>
+                    </a:lnT>
+                    <a:lnB w="12700" cap="flat" cmpd="sng" algn="ctr">
+                      <a:solidFill>
+                        <a:schemeClr val="tx1"/>
+                      </a:solidFill>
+                      <a:prstDash val="solid"/>
+                      <a:round/>
+                      <a:headEnd type="none" w="med" len="med"/>
+                      <a:tailEnd type="none" w="med" len="med"/>
+                    </a:lnB>
+                  </a:tcPr>
+                </a:tc>
+                <a:tc>
+                  <a:txBody>
+                    <a:bodyPr/>
+                    <a:lstStyle/>
+                    <a:p>
+                      <a:r>
+                        <a:rPr lang="en-US" dirty="0"/>
+                        <a:t>Rupture Disk</a:t>
+                      </a:r>
+                    </a:p>
+                  </a:txBody>
+                  <a:tcPr>
+                    <a:lnL w="12700" cap="flat" cmpd="sng" algn="ctr">
+                      <a:solidFill>
+                        <a:schemeClr val="tx1"/>
+                      </a:solidFill>
+                      <a:prstDash val="solid"/>
+                      <a:round/>
+                      <a:headEnd type="none" w="med" len="med"/>
+                      <a:tailEnd type="none" w="med" len="med"/>
+                    </a:lnL>
+                    <a:lnR w="12700" cap="flat" cmpd="sng" algn="ctr">
+                      <a:solidFill>
+                        <a:schemeClr val="tx1"/>
+                      </a:solidFill>
+                      <a:prstDash val="solid"/>
+                      <a:round/>
+                      <a:headEnd type="none" w="med" len="med"/>
+                      <a:tailEnd type="none" w="med" len="med"/>
+                    </a:lnR>
+                    <a:lnT w="12700" cap="flat" cmpd="sng" algn="ctr">
+                      <a:solidFill>
+                        <a:schemeClr val="tx1"/>
+                      </a:solidFill>
+                      <a:prstDash val="solid"/>
+                      <a:round/>
+                      <a:headEnd type="none" w="med" len="med"/>
+                      <a:tailEnd type="none" w="med" len="med"/>
+                    </a:lnT>
+                    <a:lnB w="12700" cap="flat" cmpd="sng" algn="ctr">
+                      <a:solidFill>
+                        <a:schemeClr val="tx1"/>
+                      </a:solidFill>
+                      <a:prstDash val="solid"/>
+                      <a:round/>
+                      <a:headEnd type="none" w="med" len="med"/>
+                      <a:tailEnd type="none" w="med" len="med"/>
+                    </a:lnB>
+                  </a:tcPr>
+                </a:tc>
+                <a:tc>
+                  <a:txBody>
+                    <a:bodyPr/>
+                    <a:lstStyle/>
+                    <a:p>
+                      <a:r>
+                        <a:rPr lang="en-US" dirty="0"/>
+                        <a:t>Density Meter</a:t>
+                      </a:r>
+                    </a:p>
+                  </a:txBody>
+                  <a:tcPr>
+                    <a:lnL w="12700" cap="flat" cmpd="sng" algn="ctr">
+                      <a:solidFill>
+                        <a:schemeClr val="tx1"/>
+                      </a:solidFill>
+                      <a:prstDash val="solid"/>
+                      <a:round/>
+                      <a:headEnd type="none" w="med" len="med"/>
+                      <a:tailEnd type="none" w="med" len="med"/>
+                    </a:lnL>
+                    <a:lnR w="12700" cap="flat" cmpd="sng" algn="ctr">
+                      <a:solidFill>
+                        <a:schemeClr val="tx1"/>
+                      </a:solidFill>
+                      <a:prstDash val="solid"/>
+                      <a:round/>
+                      <a:headEnd type="none" w="med" len="med"/>
+                      <a:tailEnd type="none" w="med" len="med"/>
+                    </a:lnR>
+                    <a:lnT w="12700" cap="flat" cmpd="sng" algn="ctr">
+                      <a:solidFill>
+                        <a:schemeClr val="tx1"/>
+                      </a:solidFill>
+                      <a:prstDash val="solid"/>
+                      <a:round/>
+                      <a:headEnd type="none" w="med" len="med"/>
+                      <a:tailEnd type="none" w="med" len="med"/>
+                    </a:lnT>
+                    <a:lnB w="12700" cap="flat" cmpd="sng" algn="ctr">
+                      <a:solidFill>
+                        <a:schemeClr val="tx1"/>
+                      </a:solidFill>
+                      <a:prstDash val="solid"/>
+                      <a:round/>
+                      <a:headEnd type="none" w="med" len="med"/>
+                      <a:tailEnd type="none" w="med" len="med"/>
+                    </a:lnB>
+                  </a:tcPr>
+                </a:tc>
+                <a:extLst>
+                  <a:ext uri="{0D108BD9-81ED-4DB2-BD59-A6C34878D82A}">
+                    <a16:rowId xmlns:a16="http://schemas.microsoft.com/office/drawing/2014/main" val="2986642322"/>
+                  </a:ext>
+                </a:extLst>
+              </a:tr>
+              <a:tr h="370840">
+                <a:tc>
+                  <a:txBody>
+                    <a:bodyPr/>
+                    <a:lstStyle/>
+                    <a:p>
+                      <a:r>
+                        <a:rPr lang="en-US" dirty="0"/>
+                        <a:t>Assembly</a:t>
+                      </a:r>
+                    </a:p>
+                  </a:txBody>
+                  <a:tcPr>
+                    <a:lnL w="12700" cap="flat" cmpd="sng" algn="ctr">
+                      <a:solidFill>
+                        <a:schemeClr val="tx1"/>
+                      </a:solidFill>
+                      <a:prstDash val="solid"/>
+                      <a:round/>
+                      <a:headEnd type="none" w="med" len="med"/>
+                      <a:tailEnd type="none" w="med" len="med"/>
+                    </a:lnL>
+                    <a:lnR w="12700" cap="flat" cmpd="sng" algn="ctr">
+                      <a:solidFill>
+                        <a:schemeClr val="tx1"/>
+                      </a:solidFill>
+                      <a:prstDash val="solid"/>
+                      <a:round/>
+                      <a:headEnd type="none" w="med" len="med"/>
+                      <a:tailEnd type="none" w="med" len="med"/>
+                    </a:lnR>
+                    <a:lnT w="12700" cap="flat" cmpd="sng" algn="ctr">
+                      <a:solidFill>
+                        <a:schemeClr val="tx1"/>
+                      </a:solidFill>
+                      <a:prstDash val="solid"/>
+                      <a:round/>
+                      <a:headEnd type="none" w="med" len="med"/>
+                      <a:tailEnd type="none" w="med" len="med"/>
+                    </a:lnT>
+                    <a:lnB w="12700" cap="flat" cmpd="sng" algn="ctr">
+                      <a:solidFill>
+                        <a:schemeClr val="tx1"/>
+                      </a:solidFill>
+                      <a:prstDash val="solid"/>
+                      <a:round/>
+                      <a:headEnd type="none" w="med" len="med"/>
+                      <a:tailEnd type="none" w="med" len="med"/>
+                    </a:lnB>
+                  </a:tcPr>
+                </a:tc>
+                <a:tc>
+                  <a:txBody>
+                    <a:bodyPr/>
+                    <a:lstStyle/>
+                    <a:p>
+                      <a:r>
+                        <a:rPr lang="en-US" dirty="0"/>
+                        <a:t>Steel Seal</a:t>
+                      </a:r>
+                    </a:p>
+                  </a:txBody>
+                  <a:tcPr>
+                    <a:lnL w="12700" cap="flat" cmpd="sng" algn="ctr">
+                      <a:solidFill>
+                        <a:schemeClr val="tx1"/>
+                      </a:solidFill>
+                      <a:prstDash val="solid"/>
+                      <a:round/>
+                      <a:headEnd type="none" w="med" len="med"/>
+                      <a:tailEnd type="none" w="med" len="med"/>
+                    </a:lnL>
+                    <a:lnR w="12700" cap="flat" cmpd="sng" algn="ctr">
+                      <a:solidFill>
+                        <a:schemeClr val="tx1"/>
+                      </a:solidFill>
+                      <a:prstDash val="solid"/>
+                      <a:round/>
+                      <a:headEnd type="none" w="med" len="med"/>
+                      <a:tailEnd type="none" w="med" len="med"/>
+                    </a:lnR>
+                    <a:lnT w="12700" cap="flat" cmpd="sng" algn="ctr">
+                      <a:solidFill>
+                        <a:schemeClr val="tx1"/>
+                      </a:solidFill>
+                      <a:prstDash val="solid"/>
+                      <a:round/>
+                      <a:headEnd type="none" w="med" len="med"/>
+                      <a:tailEnd type="none" w="med" len="med"/>
+                    </a:lnT>
+                    <a:lnB w="12700" cap="flat" cmpd="sng" algn="ctr">
+                      <a:solidFill>
+                        <a:schemeClr val="tx1"/>
+                      </a:solidFill>
+                      <a:prstDash val="solid"/>
+                      <a:round/>
+                      <a:headEnd type="none" w="med" len="med"/>
+                      <a:tailEnd type="none" w="med" len="med"/>
+                    </a:lnB>
+                  </a:tcPr>
+                </a:tc>
+                <a:tc>
+                  <a:txBody>
+                    <a:bodyPr/>
+                    <a:lstStyle/>
+                    <a:p>
+                      <a:r>
+                        <a:rPr lang="en-US" dirty="0"/>
+                        <a:t>Filter</a:t>
+                      </a:r>
+                    </a:p>
+                  </a:txBody>
+                  <a:tcPr>
+                    <a:lnL w="12700" cap="flat" cmpd="sng" algn="ctr">
+                      <a:solidFill>
+                        <a:schemeClr val="tx1"/>
+                      </a:solidFill>
+                      <a:prstDash val="solid"/>
+                      <a:round/>
+                      <a:headEnd type="none" w="med" len="med"/>
+                      <a:tailEnd type="none" w="med" len="med"/>
+                    </a:lnL>
+                    <a:lnR w="12700" cap="flat" cmpd="sng" algn="ctr">
+                      <a:solidFill>
+                        <a:schemeClr val="tx1"/>
+                      </a:solidFill>
+                      <a:prstDash val="solid"/>
+                      <a:round/>
+                      <a:headEnd type="none" w="med" len="med"/>
+                      <a:tailEnd type="none" w="med" len="med"/>
+                    </a:lnR>
+                    <a:lnT w="12700" cap="flat" cmpd="sng" algn="ctr">
+                      <a:solidFill>
+                        <a:schemeClr val="tx1"/>
+                      </a:solidFill>
+                      <a:prstDash val="solid"/>
+                      <a:round/>
+                      <a:headEnd type="none" w="med" len="med"/>
+                      <a:tailEnd type="none" w="med" len="med"/>
+                    </a:lnT>
+                    <a:lnB w="12700" cap="flat" cmpd="sng" algn="ctr">
+                      <a:solidFill>
+                        <a:schemeClr val="tx1"/>
+                      </a:solidFill>
+                      <a:prstDash val="solid"/>
+                      <a:round/>
+                      <a:headEnd type="none" w="med" len="med"/>
+                      <a:tailEnd type="none" w="med" len="med"/>
+                    </a:lnB>
+                  </a:tcPr>
+                </a:tc>
+                <a:tc>
+                  <a:txBody>
+                    <a:bodyPr/>
+                    <a:lstStyle/>
+                    <a:p>
+                      <a:r>
+                        <a:rPr lang="en-US" dirty="0"/>
+                        <a:t>…</a:t>
+                      </a:r>
+                    </a:p>
+                  </a:txBody>
+                  <a:tcPr>
+                    <a:lnL w="12700" cap="flat" cmpd="sng" algn="ctr">
+                      <a:solidFill>
+                        <a:schemeClr val="tx1"/>
+                      </a:solidFill>
+                      <a:prstDash val="solid"/>
+                      <a:round/>
+                      <a:headEnd type="none" w="med" len="med"/>
+                      <a:tailEnd type="none" w="med" len="med"/>
+                    </a:lnL>
+                    <a:lnR w="12700" cap="flat" cmpd="sng" algn="ctr">
+                      <a:solidFill>
+                        <a:schemeClr val="tx1"/>
+                      </a:solidFill>
+                      <a:prstDash val="solid"/>
+                      <a:round/>
+                      <a:headEnd type="none" w="med" len="med"/>
+                      <a:tailEnd type="none" w="med" len="med"/>
+                    </a:lnR>
+                    <a:lnT w="12700" cap="flat" cmpd="sng" algn="ctr">
+                      <a:solidFill>
+                        <a:schemeClr val="tx1"/>
+                      </a:solidFill>
+                      <a:prstDash val="solid"/>
+                      <a:round/>
+                      <a:headEnd type="none" w="med" len="med"/>
+                      <a:tailEnd type="none" w="med" len="med"/>
+                    </a:lnT>
+                    <a:lnB w="12700" cap="flat" cmpd="sng" algn="ctr">
+                      <a:solidFill>
+                        <a:schemeClr val="tx1"/>
+                      </a:solidFill>
+                      <a:prstDash val="solid"/>
+                      <a:round/>
+                      <a:headEnd type="none" w="med" len="med"/>
+                      <a:tailEnd type="none" w="med" len="med"/>
+                    </a:lnB>
+                  </a:tcPr>
+                </a:tc>
+                <a:extLst>
+                  <a:ext uri="{0D108BD9-81ED-4DB2-BD59-A6C34878D82A}">
+                    <a16:rowId xmlns:a16="http://schemas.microsoft.com/office/drawing/2014/main" val="2018572900"/>
+                  </a:ext>
+                </a:extLst>
+              </a:tr>
+            </a:tbl>
+          </a:graphicData>
+        </a:graphic>
+      </p:graphicFrame>
+    </p:spTree>
+    <p:extLst>
+      <p:ext uri="{BB962C8B-B14F-4D97-AF65-F5344CB8AC3E}">
+        <p14:creationId xmlns:p14="http://schemas.microsoft.com/office/powerpoint/2010/main" val="2222675766"/>
+      </p:ext>
+    </p:extLst>
+  </p:cSld>
+  <p:clrMapOvr>
+    <a:masterClrMapping/>
+  </p:clrMapOvr>
+</p:sld>
+</file>
+
 <file path=ppt/theme/theme1.xml><?xml version="1.0" encoding="utf-8"?>
 <a:theme xmlns:a="http://schemas.openxmlformats.org/drawingml/2006/main" name="Office Theme">
   <a:themeElements>

</xml_diff>